<commit_message>
Visual updates + added formula for binding streangth measure
</commit_message>
<xml_diff>
--- a/NES-Finder.pptx
+++ b/NES-Finder.pptx
@@ -111,6 +111,11 @@
       </a:defRPr>
     </a:lvl9pPr>
   </p:defaultTextStyle>
+  <p:extLst>
+    <p:ext uri="{EFAFB233-063F-42B5-8137-9DF3F51BA10A}">
+      <p15:sldGuideLst xmlns:p15="http://schemas.microsoft.com/office/powerpoint/2012/main"/>
+    </p:ext>
+  </p:extLst>
 </p:presentation>
 </file>
 
@@ -267,7 +272,7 @@
           <a:p>
             <a:fld id="{D1D1EADE-8E88-4C7C-8AC5-FB148DE4940E}" type="datetime1">
               <a:rPr lang="en-US" smtClean="0"/>
-              <a:t>6/23/2025</a:t>
+              <a:t>6/24/2025</a:t>
             </a:fld>
             <a:endParaRPr lang="en-US"/>
           </a:p>
@@ -467,7 +472,7 @@
           <a:p>
             <a:fld id="{EC3C8B9C-477D-492A-96AD-1FC2CC997A73}" type="datetime1">
               <a:rPr lang="en-US" smtClean="0"/>
-              <a:t>6/23/2025</a:t>
+              <a:t>6/24/2025</a:t>
             </a:fld>
             <a:endParaRPr lang="en-US"/>
           </a:p>
@@ -677,7 +682,7 @@
           <a:p>
             <a:fld id="{42D3AED5-E26D-4E29-B1B3-7847B6779594}" type="datetime1">
               <a:rPr lang="en-US" smtClean="0"/>
-              <a:t>6/23/2025</a:t>
+              <a:t>6/24/2025</a:t>
             </a:fld>
             <a:endParaRPr lang="en-US"/>
           </a:p>
@@ -877,7 +882,7 @@
           <a:p>
             <a:fld id="{157B6794-849E-4626-908B-D15793550EFB}" type="datetime1">
               <a:rPr lang="en-US" smtClean="0"/>
-              <a:t>6/23/2025</a:t>
+              <a:t>6/24/2025</a:t>
             </a:fld>
             <a:endParaRPr lang="en-US"/>
           </a:p>
@@ -1153,7 +1158,7 @@
           <a:p>
             <a:fld id="{63DB64E7-5594-42A3-ADBF-E95A7ACEAD64}" type="datetime1">
               <a:rPr lang="en-US" smtClean="0"/>
-              <a:t>6/23/2025</a:t>
+              <a:t>6/24/2025</a:t>
             </a:fld>
             <a:endParaRPr lang="en-US"/>
           </a:p>
@@ -1426,7 +1431,7 @@
           <a:p>
             <a:fld id="{18462B0B-D248-4FFB-8695-AD7FA4B1284A}" type="datetime1">
               <a:rPr lang="en-US" smtClean="0"/>
-              <a:t>6/23/2025</a:t>
+              <a:t>6/24/2025</a:t>
             </a:fld>
             <a:endParaRPr lang="en-US"/>
           </a:p>
@@ -1849,7 +1854,7 @@
           <a:p>
             <a:fld id="{D0378EFB-9159-4510-B73F-4F0409ADE937}" type="datetime1">
               <a:rPr lang="en-US" smtClean="0"/>
-              <a:t>6/23/2025</a:t>
+              <a:t>6/24/2025</a:t>
             </a:fld>
             <a:endParaRPr lang="en-US"/>
           </a:p>
@@ -1991,7 +1996,7 @@
           <a:p>
             <a:fld id="{89BC9412-2452-4BED-A324-9D8C115361AD}" type="datetime1">
               <a:rPr lang="en-US" smtClean="0"/>
-              <a:t>6/23/2025</a:t>
+              <a:t>6/24/2025</a:t>
             </a:fld>
             <a:endParaRPr lang="en-US"/>
           </a:p>
@@ -2104,7 +2109,7 @@
           <a:p>
             <a:fld id="{F5318F62-D251-40E8-A23C-F4CFE9FEAB41}" type="datetime1">
               <a:rPr lang="en-US" smtClean="0"/>
-              <a:t>6/23/2025</a:t>
+              <a:t>6/24/2025</a:t>
             </a:fld>
             <a:endParaRPr lang="en-US"/>
           </a:p>
@@ -2417,7 +2422,7 @@
           <a:p>
             <a:fld id="{44F76144-149E-4874-93A5-554A0357CF82}" type="datetime1">
               <a:rPr lang="en-US" smtClean="0"/>
-              <a:t>6/23/2025</a:t>
+              <a:t>6/24/2025</a:t>
             </a:fld>
             <a:endParaRPr lang="en-US"/>
           </a:p>
@@ -2710,7 +2715,7 @@
           <a:p>
             <a:fld id="{50BA65D8-0540-4835-AE5C-25D29DBA01BE}" type="datetime1">
               <a:rPr lang="en-US" smtClean="0"/>
-              <a:t>6/23/2025</a:t>
+              <a:t>6/24/2025</a:t>
             </a:fld>
             <a:endParaRPr lang="en-US"/>
           </a:p>
@@ -2948,7 +2953,7 @@
           <a:p>
             <a:fld id="{E31BA835-12AC-4E8F-955A-EA3F4DE2791F}" type="datetime1">
               <a:rPr lang="en-US" smtClean="0"/>
-              <a:t>6/23/2025</a:t>
+              <a:t>6/24/2025</a:t>
             </a:fld>
             <a:endParaRPr lang="en-US"/>
           </a:p>
@@ -3588,7 +3593,7 @@
               <a:rPr lang="en-US" sz="2700" b="0" i="0" u="none" strike="noStrike" baseline="0" dirty="0">
                 <a:latin typeface="CMR17"/>
               </a:rPr>
-              <a:t>(project num. 3)</a:t>
+              <a:t>(project #3)</a:t>
             </a:r>
             <a:br>
               <a:rPr lang="en-US" sz="2700" dirty="0"/>
@@ -3640,8 +3645,8 @@
         </p:nvSpPr>
         <p:spPr>
           <a:xfrm>
-            <a:off x="5761876" y="4935672"/>
-            <a:ext cx="6135156" cy="1005657"/>
+            <a:off x="5761876" y="5504507"/>
+            <a:ext cx="5630024" cy="436821"/>
           </a:xfrm>
         </p:spPr>
         <p:txBody>
@@ -3881,12 +3886,6 @@
           <a:bodyPr/>
           <a:lstStyle/>
           <a:p>
-            <a:pPr marL="0" indent="0">
-              <a:buNone/>
-            </a:pPr>
-            <a:endParaRPr lang="en-US" dirty="0"/>
-          </a:p>
-          <a:p>
             <a:r>
               <a:rPr lang="en-US" sz="2000" dirty="0">
                 <a:latin typeface="+mj-lt"/>
@@ -4023,13 +4022,6 @@
           <a:bodyPr/>
           <a:lstStyle/>
           <a:p>
-            <a:pPr>
-              <a:buFont typeface="Arial" panose="020B0604020202020204" pitchFamily="34" charset="0"/>
-              <a:buChar char="•"/>
-            </a:pPr>
-            <a:endParaRPr lang="en-US" dirty="0"/>
-          </a:p>
-          <a:p>
             <a:r>
               <a:rPr lang="en-US" dirty="0"/>
               <a:t>Used ESM-2 protein language model to generate embeddings from full protein sequences.</a:t>
@@ -4146,7 +4138,7 @@
         </p:nvSpPr>
         <p:spPr bwMode="auto">
           <a:xfrm>
-            <a:off x="700635" y="2229894"/>
+            <a:off x="700635" y="2139364"/>
             <a:ext cx="10390152" cy="3724096"/>
           </a:xfrm>
           <a:prstGeom prst="rect">
@@ -4717,41 +4709,6 @@
           </a:p>
         </p:txBody>
       </p:sp>
-      <p:sp>
-        <p:nvSpPr>
-          <p:cNvPr id="2" name="כותרת 1">
-            <a:extLst>
-              <a:ext uri="{FF2B5EF4-FFF2-40B4-BE49-F238E27FC236}">
-                <a16:creationId xmlns:a16="http://schemas.microsoft.com/office/drawing/2014/main" id="{DF1D8383-A6B6-08FA-F563-1585162D2B03}"/>
-              </a:ext>
-            </a:extLst>
-          </p:cNvPr>
-          <p:cNvSpPr>
-            <a:spLocks noGrp="1"/>
-          </p:cNvSpPr>
-          <p:nvPr>
-            <p:ph type="title"/>
-          </p:nvPr>
-        </p:nvSpPr>
-        <p:spPr>
-          <a:xfrm>
-            <a:off x="704088" y="914400"/>
-            <a:ext cx="3799763" cy="1473200"/>
-          </a:xfrm>
-        </p:spPr>
-        <p:txBody>
-          <a:bodyPr>
-            <a:normAutofit/>
-          </a:bodyPr>
-          <a:lstStyle/>
-          <a:p>
-            <a:r>
-              <a:rPr lang="en-US" sz="3600" dirty="0"/>
-              <a:t>Results:</a:t>
-            </a:r>
-          </a:p>
-        </p:txBody>
-      </p:sp>
       <p:cxnSp>
         <p:nvCxnSpPr>
           <p:cNvPr id="32" name="Straight Connector 31">
@@ -4822,8 +4779,8 @@
         </p:nvSpPr>
         <p:spPr bwMode="auto">
           <a:xfrm>
-            <a:off x="704088" y="2387600"/>
-            <a:ext cx="3799763" cy="3767328"/>
+            <a:off x="720731" y="2258796"/>
+            <a:ext cx="4611686" cy="2318303"/>
           </a:xfrm>
           <a:prstGeom prst="rect">
             <a:avLst/>
@@ -4862,9 +4819,37 @@
             <a:prstTxWarp prst="textNoShape">
               <a:avLst/>
             </a:prstTxWarp>
-            <a:normAutofit/>
+            <a:normAutofit fontScale="92500" lnSpcReduction="10000"/>
           </a:bodyPr>
           <a:lstStyle/>
+          <a:p>
+            <a:pPr eaLnBrk="0" fontAlgn="base" hangingPunct="0">
+              <a:spcBef>
+                <a:spcPct val="0"/>
+              </a:spcBef>
+              <a:spcAft>
+                <a:spcPts val="600"/>
+              </a:spcAft>
+            </a:pPr>
+            <a:r>
+              <a:rPr lang="en-US" altLang="en-US" dirty="0"/>
+              <a:t>Initial test: Human vs. Bacteria: Model achieved near-perfect accuracy, </a:t>
+            </a:r>
+          </a:p>
+          <a:p>
+            <a:pPr eaLnBrk="0" fontAlgn="base" hangingPunct="0">
+              <a:spcBef>
+                <a:spcPct val="0"/>
+              </a:spcBef>
+              <a:spcAft>
+                <a:spcPts val="600"/>
+              </a:spcAft>
+            </a:pPr>
+            <a:r>
+              <a:rPr lang="en-US" altLang="en-US" dirty="0"/>
+              <a:t>We deemed the task too trivial, as it could be solved by separating human proteins from bacteria (validated with t-SNE).</a:t>
+            </a:r>
+          </a:p>
           <a:p>
             <a:pPr marL="0" marR="0" lvl="0" indent="0" defTabSz="914400" rtl="0" eaLnBrk="0" fontAlgn="base" latinLnBrk="0" hangingPunct="0">
               <a:spcBef>
@@ -4879,72 +4864,7 @@
               <a:buChar char="•"/>
               <a:tabLst/>
             </a:pPr>
-            <a:r>
-              <a:rPr kumimoji="0" lang="en-US" altLang="en-US" i="0" u="none" strike="noStrike" cap="none" normalizeH="0" baseline="0" dirty="0">
-                <a:ln>
-                  <a:noFill/>
-                </a:ln>
-                <a:effectLst/>
-                <a:latin typeface="Arial" panose="020B0604020202020204" pitchFamily="34" charset="0"/>
-              </a:rPr>
-              <a:t>Initial test -Human vs. Bacteria: </a:t>
-            </a:r>
-            <a:r>
-              <a:rPr kumimoji="0" lang="en-US" altLang="en-US" b="0" i="0" u="none" strike="noStrike" cap="none" normalizeH="0" baseline="0" dirty="0">
-                <a:ln>
-                  <a:noFill/>
-                </a:ln>
-                <a:effectLst/>
-                <a:latin typeface="Arial" panose="020B0604020202020204" pitchFamily="34" charset="0"/>
-              </a:rPr>
-              <a:t>Model achieved near-perfect accuracy, </a:t>
-            </a:r>
-          </a:p>
-          <a:p>
-            <a:pPr marL="0" marR="0" lvl="0" indent="0" defTabSz="914400" rtl="0" eaLnBrk="0" fontAlgn="base" latinLnBrk="0" hangingPunct="0">
-              <a:spcBef>
-                <a:spcPct val="0"/>
-              </a:spcBef>
-              <a:spcAft>
-                <a:spcPts val="600"/>
-              </a:spcAft>
-              <a:buClrTx/>
-              <a:buSzTx/>
-              <a:buNone/>
-              <a:tabLst/>
-            </a:pPr>
-            <a:r>
-              <a:rPr kumimoji="0" lang="en-US" altLang="en-US" b="0" i="0" u="none" strike="noStrike" cap="none" normalizeH="0" baseline="0" dirty="0">
-                <a:ln>
-                  <a:noFill/>
-                </a:ln>
-                <a:effectLst/>
-                <a:latin typeface="Arial" panose="020B0604020202020204" pitchFamily="34" charset="0"/>
-              </a:rPr>
-              <a:t>but task was too trivial due to species separation (validated with t-SNE).</a:t>
-            </a:r>
-          </a:p>
-          <a:p>
-            <a:pPr marL="0" marR="0" lvl="0" indent="0" defTabSz="914400" rtl="0" eaLnBrk="0" fontAlgn="base" latinLnBrk="0" hangingPunct="0">
-              <a:spcBef>
-                <a:spcPct val="0"/>
-              </a:spcBef>
-              <a:spcAft>
-                <a:spcPts val="600"/>
-              </a:spcAft>
-              <a:buClrTx/>
-              <a:buSzTx/>
-              <a:buFontTx/>
-              <a:buChar char="•"/>
-              <a:tabLst/>
-            </a:pPr>
-            <a:endParaRPr kumimoji="0" lang="en-US" altLang="en-US" b="0" i="0" u="none" strike="noStrike" cap="none" normalizeH="0" baseline="0" dirty="0">
-              <a:ln>
-                <a:noFill/>
-              </a:ln>
-              <a:effectLst/>
-              <a:latin typeface="Arial" panose="020B0604020202020204" pitchFamily="34" charset="0"/>
-            </a:endParaRPr>
+            <a:endParaRPr lang="en-US" altLang="en-US" dirty="0"/>
           </a:p>
         </p:txBody>
       </p:sp>
@@ -4977,7 +4897,7 @@
         </p:blipFill>
         <p:spPr>
           <a:xfrm>
-            <a:off x="4981575" y="735286"/>
+            <a:off x="5470458" y="536114"/>
             <a:ext cx="6495042" cy="5419642"/>
           </a:xfrm>
           <a:prstGeom prst="rect">
@@ -4985,6 +4905,41 @@
           </a:prstGeom>
         </p:spPr>
       </p:pic>
+      <p:sp>
+        <p:nvSpPr>
+          <p:cNvPr id="6" name="כותרת 1">
+            <a:extLst>
+              <a:ext uri="{FF2B5EF4-FFF2-40B4-BE49-F238E27FC236}">
+                <a16:creationId xmlns:a16="http://schemas.microsoft.com/office/drawing/2014/main" id="{D3206D66-C12B-5DB2-BF10-8280BE4A67FC}"/>
+              </a:ext>
+            </a:extLst>
+          </p:cNvPr>
+          <p:cNvSpPr>
+            <a:spLocks noGrp="1"/>
+          </p:cNvSpPr>
+          <p:nvPr>
+            <p:ph type="title"/>
+          </p:nvPr>
+        </p:nvSpPr>
+        <p:spPr>
+          <a:xfrm>
+            <a:off x="704088" y="914400"/>
+            <a:ext cx="2147754" cy="796705"/>
+          </a:xfrm>
+        </p:spPr>
+        <p:txBody>
+          <a:bodyPr>
+            <a:normAutofit/>
+          </a:bodyPr>
+          <a:lstStyle/>
+          <a:p>
+            <a:r>
+              <a:rPr lang="en-US" sz="4000" dirty="0"/>
+              <a:t>Result</a:t>
+            </a:r>
+          </a:p>
+        </p:txBody>
+      </p:sp>
     </p:spTree>
     <p:extLst>
       <p:ext uri="{BB962C8B-B14F-4D97-AF65-F5344CB8AC3E}">
@@ -5205,7 +5160,7 @@
         <p:spPr>
           <a:xfrm>
             <a:off x="704088" y="2231136"/>
-            <a:ext cx="6001512" cy="3931920"/>
+            <a:ext cx="5533750" cy="1725228"/>
           </a:xfrm>
         </p:spPr>
         <p:txBody>
@@ -5222,7 +5177,7 @@
           <a:p>
             <a:r>
               <a:rPr lang="en-US" dirty="0"/>
-              <a:t>Poor results </a:t>
+              <a:t>Results were Poor results </a:t>
             </a:r>
           </a:p>
         </p:txBody>
@@ -5242,15 +5197,20 @@
           <p:nvPr/>
         </p:nvPicPr>
         <p:blipFill>
-          <a:blip r:embed="rId2"/>
-          <a:stretch>
-            <a:fillRect/>
-          </a:stretch>
+          <a:blip r:embed="rId2">
+            <a:extLst>
+              <a:ext uri="{28A0092B-C50C-407E-A947-70E740481C1C}">
+                <a14:useLocalDpi xmlns:a14="http://schemas.microsoft.com/office/drawing/2010/main" val="0"/>
+              </a:ext>
+            </a:extLst>
+          </a:blip>
+          <a:srcRect/>
+          <a:stretch/>
         </p:blipFill>
         <p:spPr>
           <a:xfrm>
-            <a:off x="6705600" y="914400"/>
-            <a:ext cx="5170842" cy="5157914"/>
+            <a:off x="6715328" y="914400"/>
+            <a:ext cx="5151385" cy="5157914"/>
           </a:xfrm>
           <a:prstGeom prst="rect">
             <a:avLst/>
@@ -5492,7 +5452,7 @@
             </a:pPr>
             <a:r>
               <a:rPr lang="en-US" dirty="0"/>
-              <a:t>Final test: Model evaluated on human non-binders with AUC = 0.79, showing good predictive performance.</a:t>
+              <a:t>Final test: Model evaluated on human non-binders with AUC = 0.79, showing decent predictive ability.</a:t>
             </a:r>
           </a:p>
           <a:p>
@@ -5737,51 +5697,247 @@
           </a:fontRef>
         </p:style>
       </p:cxnSp>
-      <p:sp>
-        <p:nvSpPr>
-          <p:cNvPr id="3" name="מציין מיקום תוכן 2">
-            <a:extLst>
-              <a:ext uri="{FF2B5EF4-FFF2-40B4-BE49-F238E27FC236}">
-                <a16:creationId xmlns:a16="http://schemas.microsoft.com/office/drawing/2014/main" id="{93BC4B4B-2531-337C-F8B7-0F9C0C2DCDF0}"/>
-              </a:ext>
-            </a:extLst>
-          </p:cNvPr>
-          <p:cNvSpPr>
-            <a:spLocks noGrp="1"/>
-          </p:cNvSpPr>
-          <p:nvPr>
-            <p:ph idx="1"/>
-          </p:nvPr>
-        </p:nvSpPr>
-        <p:spPr>
-          <a:xfrm>
-            <a:off x="704088" y="2231136"/>
-            <a:ext cx="4316146" cy="3931920"/>
-          </a:xfrm>
-        </p:spPr>
-        <p:txBody>
-          <a:bodyPr>
-            <a:normAutofit/>
-          </a:bodyPr>
-          <a:lstStyle/>
-          <a:p>
-            <a:r>
-              <a:rPr lang="en-US" b="0" i="0" dirty="0">
-                <a:effectLst/>
-                <a:latin typeface="gg sans"/>
-              </a:rPr>
-              <a:t>We examined the correlation between a protein's model score and the experimental binding strength</a:t>
-            </a:r>
-            <a:r>
-              <a:rPr lang="en-US" dirty="0">
-                <a:latin typeface="gg sans"/>
-              </a:rPr>
-              <a:t>.</a:t>
-            </a:r>
-            <a:endParaRPr lang="en-US" dirty="0"/>
-          </a:p>
-        </p:txBody>
-      </p:sp>
+      <mc:AlternateContent xmlns:mc="http://schemas.openxmlformats.org/markup-compatibility/2006">
+        <mc:Choice xmlns:a14="http://schemas.microsoft.com/office/drawing/2010/main" Requires="a14">
+          <p:sp>
+            <p:nvSpPr>
+              <p:cNvPr id="3" name="מציין מיקום תוכן 2">
+                <a:extLst>
+                  <a:ext uri="{FF2B5EF4-FFF2-40B4-BE49-F238E27FC236}">
+                    <a16:creationId xmlns:a16="http://schemas.microsoft.com/office/drawing/2014/main" id="{93BC4B4B-2531-337C-F8B7-0F9C0C2DCDF0}"/>
+                  </a:ext>
+                </a:extLst>
+              </p:cNvPr>
+              <p:cNvSpPr>
+                <a:spLocks noGrp="1"/>
+              </p:cNvSpPr>
+              <p:nvPr>
+                <p:ph idx="1"/>
+              </p:nvPr>
+            </p:nvSpPr>
+            <p:spPr>
+              <a:xfrm>
+                <a:off x="704088" y="2231136"/>
+                <a:ext cx="4316146" cy="3712464"/>
+              </a:xfrm>
+            </p:spPr>
+            <p:txBody>
+              <a:bodyPr>
+                <a:normAutofit fontScale="92500"/>
+              </a:bodyPr>
+              <a:lstStyle/>
+              <a:p>
+                <a:r>
+                  <a:rPr lang="en-US" b="0" i="0" dirty="0">
+                    <a:effectLst/>
+                    <a:latin typeface="Arial (Body)"/>
+                  </a:rPr>
+                  <a:t>We examined the correlation between a protein's model score and the experimental binding strength</a:t>
+                </a:r>
+                <a:r>
+                  <a:rPr lang="en-US" dirty="0">
+                    <a:latin typeface="Arial (Body)"/>
+                  </a:rPr>
+                  <a:t>.</a:t>
+                </a:r>
+              </a:p>
+              <a:p>
+                <a:r>
+                  <a:rPr lang="en-US" dirty="0">
+                    <a:latin typeface="Arial (Body)"/>
+                  </a:rPr>
+                  <a:t>The binding strength is measured by the ratio:</a:t>
+                </a:r>
+              </a:p>
+              <a:p>
+                <a:pPr marL="914400" lvl="2" indent="0">
+                  <a:buNone/>
+                </a:pPr>
+                <a14:m>
+                  <m:oMathPara xmlns:m="http://schemas.openxmlformats.org/officeDocument/2006/math">
+                    <m:oMathParaPr>
+                      <m:jc m:val="centerGroup"/>
+                    </m:oMathParaPr>
+                    <m:oMath xmlns:m="http://schemas.openxmlformats.org/officeDocument/2006/math">
+                      <m:f>
+                        <m:fPr>
+                          <m:ctrlPr>
+                            <a:rPr lang="en-AU" sz="2200" i="1">
+                              <a:latin typeface="Cambria Math" panose="02040503050406030204" pitchFamily="18" charset="0"/>
+                            </a:rPr>
+                          </m:ctrlPr>
+                        </m:fPr>
+                        <m:num>
+                          <m:sSup>
+                            <m:sSupPr>
+                              <m:ctrlPr>
+                                <a:rPr lang="en-AU" sz="2200" i="1" smtClean="0">
+                                  <a:latin typeface="Cambria Math" panose="02040503050406030204" pitchFamily="18" charset="0"/>
+                                </a:rPr>
+                              </m:ctrlPr>
+                            </m:sSupPr>
+                            <m:e>
+                              <m:r>
+                                <a:rPr lang="en-AU" sz="2200" i="1">
+                                  <a:latin typeface="Cambria Math" panose="02040503050406030204" pitchFamily="18" charset="0"/>
+                                </a:rPr>
+                                <m:t>𝑖𝐵𝐴𝑄</m:t>
+                              </m:r>
+                            </m:e>
+                            <m:sup>
+                              <m:r>
+                                <a:rPr lang="en-AU" sz="2200" b="0" i="1" smtClean="0">
+                                  <a:latin typeface="Cambria Math" panose="02040503050406030204" pitchFamily="18" charset="0"/>
+                                </a:rPr>
+                                <m:t>∗</m:t>
+                              </m:r>
+                            </m:sup>
+                          </m:sSup>
+                          <m:r>
+                            <a:rPr lang="en-AU" sz="2200" i="1">
+                              <a:latin typeface="Cambria Math" panose="02040503050406030204" pitchFamily="18" charset="0"/>
+                            </a:rPr>
+                            <m:t>[</m:t>
+                          </m:r>
+                          <m:r>
+                            <a:rPr lang="en-AU" sz="2200" i="1">
+                              <a:latin typeface="Cambria Math" panose="02040503050406030204" pitchFamily="18" charset="0"/>
+                            </a:rPr>
+                            <m:t>𝐶𝑅𝑀</m:t>
+                          </m:r>
+                          <m:r>
+                            <a:rPr lang="en-AU" sz="2200" i="1">
+                              <a:latin typeface="Cambria Math" panose="02040503050406030204" pitchFamily="18" charset="0"/>
+                            </a:rPr>
+                            <m:t>1</m:t>
+                          </m:r>
+                          <m:r>
+                            <a:rPr lang="en-AU" sz="2200" i="1">
+                              <a:latin typeface="Cambria Math" panose="02040503050406030204" pitchFamily="18" charset="0"/>
+                            </a:rPr>
+                            <m:t>+</m:t>
+                          </m:r>
+                          <m:r>
+                            <a:rPr lang="en-AU" sz="2200" i="1">
+                              <a:latin typeface="Cambria Math" panose="02040503050406030204" pitchFamily="18" charset="0"/>
+                            </a:rPr>
+                            <m:t>𝑅𝑎𝑛𝐺𝑇𝑃</m:t>
+                          </m:r>
+                          <m:r>
+                            <a:rPr lang="en-AU" sz="2200" i="1">
+                              <a:latin typeface="Cambria Math" panose="02040503050406030204" pitchFamily="18" charset="0"/>
+                            </a:rPr>
+                            <m:t>]</m:t>
+                          </m:r>
+                        </m:num>
+                        <m:den>
+                          <m:r>
+                            <a:rPr lang="en-AU" sz="2200" i="1">
+                              <a:latin typeface="Cambria Math" panose="02040503050406030204" pitchFamily="18" charset="0"/>
+                            </a:rPr>
+                            <m:t>𝑖𝐵𝐴𝑄</m:t>
+                          </m:r>
+                          <m:d>
+                            <m:dPr>
+                              <m:begChr m:val="["/>
+                              <m:endChr m:val="]"/>
+                              <m:ctrlPr>
+                                <a:rPr lang="en-AU" sz="2200" i="1">
+                                  <a:latin typeface="Cambria Math" panose="02040503050406030204" pitchFamily="18" charset="0"/>
+                                </a:rPr>
+                              </m:ctrlPr>
+                            </m:dPr>
+                            <m:e>
+                              <m:r>
+                                <a:rPr lang="en-AU" sz="2200" i="1">
+                                  <a:latin typeface="Cambria Math" panose="02040503050406030204" pitchFamily="18" charset="0"/>
+                                </a:rPr>
+                                <m:t>𝐼𝑛𝑝𝑢𝑡</m:t>
+                              </m:r>
+                            </m:e>
+                          </m:d>
+                        </m:den>
+                      </m:f>
+                    </m:oMath>
+                  </m:oMathPara>
+                </a14:m>
+                <a:endParaRPr lang="en-AU" sz="2200" b="0" dirty="0">
+                  <a:latin typeface="Arial (Body)"/>
+                </a:endParaRPr>
+              </a:p>
+              <a:p>
+                <a:pPr marL="914400" lvl="2" indent="0">
+                  <a:buNone/>
+                </a:pPr>
+                <a:endParaRPr lang="en-AU" sz="2200" dirty="0">
+                  <a:latin typeface="Arial (Body)"/>
+                </a:endParaRPr>
+              </a:p>
+              <a:p>
+                <a:pPr marL="914400" lvl="2" indent="0">
+                  <a:buNone/>
+                </a:pPr>
+                <a:r>
+                  <a:rPr lang="en-AU" sz="1000" b="0" dirty="0">
+                    <a:latin typeface="Arial (Body)"/>
+                  </a:rPr>
+                  <a:t>*</a:t>
+                </a:r>
+                <a:r>
+                  <a:rPr lang="en-AU" sz="1000" dirty="0"/>
+                  <a:t> Intensity-Based Absolute Quantification</a:t>
+                </a:r>
+                <a:endParaRPr lang="en-AU" sz="1000" b="0" dirty="0">
+                  <a:latin typeface="Arial (Body)"/>
+                </a:endParaRPr>
+              </a:p>
+            </p:txBody>
+          </p:sp>
+        </mc:Choice>
+        <mc:Fallback>
+          <p:sp>
+            <p:nvSpPr>
+              <p:cNvPr id="3" name="מציין מיקום תוכן 2">
+                <a:extLst>
+                  <a:ext uri="{FF2B5EF4-FFF2-40B4-BE49-F238E27FC236}">
+                    <a16:creationId xmlns:a16="http://schemas.microsoft.com/office/drawing/2014/main" id="{93BC4B4B-2531-337C-F8B7-0F9C0C2DCDF0}"/>
+                  </a:ext>
+                </a:extLst>
+              </p:cNvPr>
+              <p:cNvSpPr>
+                <a:spLocks noGrp="1" noRot="1" noChangeAspect="1" noMove="1" noResize="1" noEditPoints="1" noAdjustHandles="1" noChangeArrowheads="1" noChangeShapeType="1" noTextEdit="1"/>
+              </p:cNvSpPr>
+              <p:nvPr>
+                <p:ph idx="1"/>
+              </p:nvPr>
+            </p:nvSpPr>
+            <p:spPr>
+              <a:xfrm>
+                <a:off x="704088" y="2231136"/>
+                <a:ext cx="4316146" cy="3712464"/>
+              </a:xfrm>
+              <a:blipFill>
+                <a:blip r:embed="rId2"/>
+                <a:stretch>
+                  <a:fillRect l="-1130" t="-164" b="-493"/>
+                </a:stretch>
+              </a:blipFill>
+            </p:spPr>
+            <p:txBody>
+              <a:bodyPr/>
+              <a:lstStyle/>
+              <a:p>
+                <a:r>
+                  <a:rPr lang="en-IL">
+                    <a:noFill/>
+                  </a:rPr>
+                  <a:t> </a:t>
+                </a:r>
+              </a:p>
+            </p:txBody>
+          </p:sp>
+        </mc:Fallback>
+      </mc:AlternateContent>
       <p:pic>
         <p:nvPicPr>
           <p:cNvPr id="5" name="תמונה 4" descr="תמונה שמכילה טקסט, צילום מסך, קו, עלילה&#10;&#10;תוכן שנוצר על-ידי בינה מלאכותית עשוי להיות שגוי.">
@@ -5797,7 +5953,7 @@
           <p:nvPr/>
         </p:nvPicPr>
         <p:blipFill>
-          <a:blip r:embed="rId2">
+          <a:blip r:embed="rId3">
             <a:extLst>
               <a:ext uri="{28A0092B-C50C-407E-A947-70E740481C1C}">
                 <a14:useLocalDpi xmlns:a14="http://schemas.microsoft.com/office/drawing/2010/main" val="0"/>

</xml_diff>